<commit_message>
refactor: update slide again
</commit_message>
<xml_diff>
--- a/apps/video/public/the-city-after-asphalt-editorial-forest.pptx
+++ b/apps/video/public/the-city-after-asphalt-editorial-forest.pptx
@@ -2,35 +2,35 @@
 <file path=ppt/presentation.xml><?xml version="1.0" encoding="utf-8"?>
 <p:presentation xmlns:r="http://schemas.openxmlformats.org/officeDocument/2006/relationships" xmlns:p="http://schemas.openxmlformats.org/presentationml/2006/main" embedTrueTypeFonts="true" saveSubsetFonts="true">
   <p:sldMasterIdLst>
-    <p:sldMasterId xmlns:r="http://schemas.openxmlformats.org/officeDocument/2006/relationships" id="2147483648" r:id="R5988a3d77e85494d"/>
+    <p:sldMasterId xmlns:r="http://schemas.openxmlformats.org/officeDocument/2006/relationships" id="2147483648" r:id="R2b7a4f8593524136"/>
   </p:sldMasterIdLst>
   <p:notesMasterIdLst>
-    <p:notesMasterId xmlns:r="http://schemas.openxmlformats.org/officeDocument/2006/relationships" r:id="R061a51ddc2034ced"/>
+    <p:notesMasterId xmlns:r="http://schemas.openxmlformats.org/officeDocument/2006/relationships" r:id="Re82f5bd1a6b3434f"/>
   </p:notesMasterIdLst>
   <p:sldIdLst>
-    <p:sldId xmlns:r="http://schemas.openxmlformats.org/officeDocument/2006/relationships" id="256" r:id="Raa5a59ce7e7a4bf0"/>
-    <p:sldId xmlns:r="http://schemas.openxmlformats.org/officeDocument/2006/relationships" id="257" r:id="Rd59587c9ee5641b2"/>
-    <p:sldId xmlns:r="http://schemas.openxmlformats.org/officeDocument/2006/relationships" id="258" r:id="Rdc7253e0fcb34433"/>
-    <p:sldId xmlns:r="http://schemas.openxmlformats.org/officeDocument/2006/relationships" id="259" r:id="R101373342a4c4878"/>
-    <p:sldId xmlns:r="http://schemas.openxmlformats.org/officeDocument/2006/relationships" id="260" r:id="R5667da2c00cd4953"/>
-    <p:sldId xmlns:r="http://schemas.openxmlformats.org/officeDocument/2006/relationships" id="261" r:id="R887d364a91324952"/>
-    <p:sldId xmlns:r="http://schemas.openxmlformats.org/officeDocument/2006/relationships" id="262" r:id="Rae32e2b08b124a45"/>
-    <p:sldId xmlns:r="http://schemas.openxmlformats.org/officeDocument/2006/relationships" id="263" r:id="Re5e5cac123434fbe"/>
+    <p:sldId xmlns:r="http://schemas.openxmlformats.org/officeDocument/2006/relationships" id="256" r:id="Rc252396978ef4061"/>
+    <p:sldId xmlns:r="http://schemas.openxmlformats.org/officeDocument/2006/relationships" id="257" r:id="R69ebc79d8add439d"/>
+    <p:sldId xmlns:r="http://schemas.openxmlformats.org/officeDocument/2006/relationships" id="258" r:id="Reb74c137d8aa44fe"/>
+    <p:sldId xmlns:r="http://schemas.openxmlformats.org/officeDocument/2006/relationships" id="259" r:id="R88926c81b5a9469d"/>
+    <p:sldId xmlns:r="http://schemas.openxmlformats.org/officeDocument/2006/relationships" id="260" r:id="R6a3040c72c32421f"/>
+    <p:sldId xmlns:r="http://schemas.openxmlformats.org/officeDocument/2006/relationships" id="261" r:id="R9d2731b7da4244e4"/>
+    <p:sldId xmlns:r="http://schemas.openxmlformats.org/officeDocument/2006/relationships" id="262" r:id="Rdbe43d75f5eb4086"/>
+    <p:sldId xmlns:r="http://schemas.openxmlformats.org/officeDocument/2006/relationships" id="263" r:id="R81777c2a86da476e"/>
   </p:sldIdLst>
   <p:sldSz cx="12192000" cy="6858000"/>
   <p:notesSz cx="6858000" cy="9144000"/>
   <p:embeddedFontLst>
     <p:embeddedFont>
       <p:font typeface="Archivo Black Display"/>
-      <p:regular xmlns:r="http://schemas.openxmlformats.org/officeDocument/2006/relationships" r:id="R7128d8c667f24464"/>
+      <p:regular xmlns:r="http://schemas.openxmlformats.org/officeDocument/2006/relationships" r:id="R0e31eee670fd4a54"/>
     </p:embeddedFont>
     <p:embeddedFont>
       <p:font typeface="Space Grotesk Text"/>
-      <p:regular xmlns:r="http://schemas.openxmlformats.org/officeDocument/2006/relationships" r:id="R78185e3ab3f24edf"/>
+      <p:regular xmlns:r="http://schemas.openxmlformats.org/officeDocument/2006/relationships" r:id="R82223c0aaf24416d"/>
     </p:embeddedFont>
     <p:embeddedFont>
       <p:font typeface="JetBrains Mono"/>
-      <p:regular xmlns:r="http://schemas.openxmlformats.org/officeDocument/2006/relationships" r:id="R9e3e16408fb54a97"/>
+      <p:regular xmlns:r="http://schemas.openxmlformats.org/officeDocument/2006/relationships" r:id="Rf442c0dd649e4ff0"/>
     </p:embeddedFont>
     <p:embeddedFont>
       <p:font typeface="Source Serif 4 Medium"/>
@@ -480,22 +480,22 @@
           </a:p>
           <a:p xmlns:a="http://schemas.openxmlformats.org/drawingml/2006/main">
             <a:r>
-              <a:t>- editorial-forest.pptx — user-supplied visual reference.</a:t>
-            </a:r>
-          </a:p>
-          <a:p xmlns:a="http://schemas.openxmlformats.org/drawingml/2006/main">
-            <a:r>
-              <a:t>- make-something-strange-creative-mode(1).pptx — user-supplied editable layout reference.</a:t>
-            </a:r>
-          </a:p>
-          <a:p xmlns:a="http://schemas.openxmlformats.org/drawingml/2006/main">
-            <a:r>
-              <a:t>- https://github.com/zarazhangrui/beautiful-html-templates/blob/main/templates/editorial-forest/design.md — Editorial Forest typography and layout specification.</a:t>
-            </a:r>
-          </a:p>
-          <a:p xmlns:a="http://schemas.openxmlformats.org/drawingml/2006/main">
-            <a:r>
-              <a:t>- 4106acdf-6ce8-4dae-8708-0a996b804717.png — user-supplied five-topic bento reference.</a:t>
+              <a:t>- editorial-forest.pptx</a:t>
+            </a:r>
+          </a:p>
+          <a:p xmlns:a="http://schemas.openxmlformats.org/drawingml/2006/main">
+            <a:r>
+              <a:t>- make-something-strange-creative-mode(1).pptx</a:t>
+            </a:r>
+          </a:p>
+          <a:p xmlns:a="http://schemas.openxmlformats.org/drawingml/2006/main">
+            <a:r>
+              <a:t>- https://github.com/zarazhangrui/frontend-slides</a:t>
+            </a:r>
+          </a:p>
+          <a:p xmlns:a="http://schemas.openxmlformats.org/drawingml/2006/main">
+            <a:r>
+              <a:t>- 4106acdf-6ce8-4dae-8708-0a996b804717.png</a:t>
             </a:r>
           </a:p>
           <a:p xmlns:a="http://schemas.openxmlformats.org/drawingml/2006/main">
@@ -505,12 +505,7 @@
           </a:p>
           <a:p xmlns:a="http://schemas.openxmlformats.org/drawingml/2006/main">
             <a:r>
-              <a:t/>
-            </a:r>
-          </a:p>
-          <a:p xmlns:a="http://schemas.openxmlformats.org/drawingml/2006/main">
-            <a:r>
-              <a:t>All figures and block conditions are illustrative editorial scenarios, not measured findings or forecasts. The cover follows the Editorial Forest cover anatomy directly: one green field, one pink hero headline, a mono topbar, a monogram circle, and a single footline.</a:t>
+              <a:t>Illustrative scenario data; not measured or forecast.</a:t>
             </a:r>
           </a:p>
         </p:txBody>
@@ -585,22 +580,22 @@
           </a:p>
           <a:p xmlns:a="http://schemas.openxmlformats.org/drawingml/2006/main">
             <a:r>
-              <a:t>- editorial-forest.pptx — user-supplied visual reference.</a:t>
-            </a:r>
-          </a:p>
-          <a:p xmlns:a="http://schemas.openxmlformats.org/drawingml/2006/main">
-            <a:r>
-              <a:t>- make-something-strange-creative-mode(1).pptx — user-supplied editable layout reference.</a:t>
-            </a:r>
-          </a:p>
-          <a:p xmlns:a="http://schemas.openxmlformats.org/drawingml/2006/main">
-            <a:r>
-              <a:t>- https://github.com/zarazhangrui/beautiful-html-templates/blob/main/templates/editorial-forest/design.md — Editorial Forest typography and layout specification.</a:t>
-            </a:r>
-          </a:p>
-          <a:p xmlns:a="http://schemas.openxmlformats.org/drawingml/2006/main">
-            <a:r>
-              <a:t>- 4106acdf-6ce8-4dae-8708-0a996b804717.png — user-supplied five-topic bento reference.</a:t>
+              <a:t>- editorial-forest.pptx</a:t>
+            </a:r>
+          </a:p>
+          <a:p xmlns:a="http://schemas.openxmlformats.org/drawingml/2006/main">
+            <a:r>
+              <a:t>- make-something-strange-creative-mode(1).pptx</a:t>
+            </a:r>
+          </a:p>
+          <a:p xmlns:a="http://schemas.openxmlformats.org/drawingml/2006/main">
+            <a:r>
+              <a:t>- https://github.com/zarazhangrui/frontend-slides</a:t>
+            </a:r>
+          </a:p>
+          <a:p xmlns:a="http://schemas.openxmlformats.org/drawingml/2006/main">
+            <a:r>
+              <a:t>- 4106acdf-6ce8-4dae-8708-0a996b804717.png</a:t>
             </a:r>
           </a:p>
           <a:p xmlns:a="http://schemas.openxmlformats.org/drawingml/2006/main">
@@ -610,12 +605,7 @@
           </a:p>
           <a:p xmlns:a="http://schemas.openxmlformats.org/drawingml/2006/main">
             <a:r>
-              <a:t/>
-            </a:r>
-          </a:p>
-          <a:p xmlns:a="http://schemas.openxmlformats.org/drawingml/2006/main">
-            <a:r>
-              <a:t>All figures and block conditions are illustrative editorial scenarios, not measured findings or forecasts. Agenda bento follows the user-supplied five-topic Editorial Forest reference image.</a:t>
+              <a:t>Illustrative scenario data; not measured or forecast.</a:t>
             </a:r>
           </a:p>
         </p:txBody>
@@ -690,22 +680,22 @@
           </a:p>
           <a:p xmlns:a="http://schemas.openxmlformats.org/drawingml/2006/main">
             <a:r>
-              <a:t>- editorial-forest.pptx — user-supplied visual reference.</a:t>
-            </a:r>
-          </a:p>
-          <a:p xmlns:a="http://schemas.openxmlformats.org/drawingml/2006/main">
-            <a:r>
-              <a:t>- make-something-strange-creative-mode(1).pptx — user-supplied editable layout reference.</a:t>
-            </a:r>
-          </a:p>
-          <a:p xmlns:a="http://schemas.openxmlformats.org/drawingml/2006/main">
-            <a:r>
-              <a:t>- https://github.com/zarazhangrui/beautiful-html-templates/blob/main/templates/editorial-forest/design.md — Editorial Forest typography and layout specification.</a:t>
-            </a:r>
-          </a:p>
-          <a:p xmlns:a="http://schemas.openxmlformats.org/drawingml/2006/main">
-            <a:r>
-              <a:t>- 4106acdf-6ce8-4dae-8708-0a996b804717.png — user-supplied five-topic bento reference.</a:t>
+              <a:t>- editorial-forest.pptx</a:t>
+            </a:r>
+          </a:p>
+          <a:p xmlns:a="http://schemas.openxmlformats.org/drawingml/2006/main">
+            <a:r>
+              <a:t>- make-something-strange-creative-mode(1).pptx</a:t>
+            </a:r>
+          </a:p>
+          <a:p xmlns:a="http://schemas.openxmlformats.org/drawingml/2006/main">
+            <a:r>
+              <a:t>- https://github.com/zarazhangrui/frontend-slides</a:t>
+            </a:r>
+          </a:p>
+          <a:p xmlns:a="http://schemas.openxmlformats.org/drawingml/2006/main">
+            <a:r>
+              <a:t>- 4106acdf-6ce8-4dae-8708-0a996b804717.png</a:t>
             </a:r>
           </a:p>
           <a:p xmlns:a="http://schemas.openxmlformats.org/drawingml/2006/main">
@@ -715,12 +705,7 @@
           </a:p>
           <a:p xmlns:a="http://schemas.openxmlformats.org/drawingml/2006/main">
             <a:r>
-              <a:t/>
-            </a:r>
-          </a:p>
-          <a:p xmlns:a="http://schemas.openxmlformats.org/drawingml/2006/main">
-            <a:r>
-              <a:t>All figures and block conditions are illustrative editorial scenarios, not measured findings or forecasts. The premise uses one dominant pink field and a hairline-separated support row. Its topbar, content, and footline share the same 88–1192 editorial grid.</a:t>
+              <a:t>Illustrative scenario data; not measured or forecast.</a:t>
             </a:r>
           </a:p>
         </p:txBody>
@@ -795,22 +780,22 @@
           </a:p>
           <a:p xmlns:a="http://schemas.openxmlformats.org/drawingml/2006/main">
             <a:r>
-              <a:t>- editorial-forest.pptx — user-supplied visual reference.</a:t>
-            </a:r>
-          </a:p>
-          <a:p xmlns:a="http://schemas.openxmlformats.org/drawingml/2006/main">
-            <a:r>
-              <a:t>- make-something-strange-creative-mode(1).pptx — user-supplied editable layout reference.</a:t>
-            </a:r>
-          </a:p>
-          <a:p xmlns:a="http://schemas.openxmlformats.org/drawingml/2006/main">
-            <a:r>
-              <a:t>- https://github.com/zarazhangrui/beautiful-html-templates/blob/main/templates/editorial-forest/design.md — Editorial Forest typography and layout specification.</a:t>
-            </a:r>
-          </a:p>
-          <a:p xmlns:a="http://schemas.openxmlformats.org/drawingml/2006/main">
-            <a:r>
-              <a:t>- 4106acdf-6ce8-4dae-8708-0a996b804717.png — user-supplied five-topic bento reference.</a:t>
+              <a:t>- editorial-forest.pptx</a:t>
+            </a:r>
+          </a:p>
+          <a:p xmlns:a="http://schemas.openxmlformats.org/drawingml/2006/main">
+            <a:r>
+              <a:t>- make-something-strange-creative-mode(1).pptx</a:t>
+            </a:r>
+          </a:p>
+          <a:p xmlns:a="http://schemas.openxmlformats.org/drawingml/2006/main">
+            <a:r>
+              <a:t>- https://github.com/zarazhangrui/frontend-slides</a:t>
+            </a:r>
+          </a:p>
+          <a:p xmlns:a="http://schemas.openxmlformats.org/drawingml/2006/main">
+            <a:r>
+              <a:t>- 4106acdf-6ce8-4dae-8708-0a996b804717.png</a:t>
             </a:r>
           </a:p>
           <a:p xmlns:a="http://schemas.openxmlformats.org/drawingml/2006/main">
@@ -820,12 +805,7 @@
           </a:p>
           <a:p xmlns:a="http://schemas.openxmlformats.org/drawingml/2006/main">
             <a:r>
-              <a:t/>
-            </a:r>
-          </a:p>
-          <a:p xmlns:a="http://schemas.openxmlformats.org/drawingml/2006/main">
-            <a:r>
-              <a:t>All figures and block conditions are illustrative editorial scenarios, not measured findings or forecasts. Targets are invented design prompts for discussion.</a:t>
+              <a:t>Illustrative scenario data; not measured or forecast.</a:t>
             </a:r>
           </a:p>
         </p:txBody>
@@ -900,22 +880,22 @@
           </a:p>
           <a:p xmlns:a="http://schemas.openxmlformats.org/drawingml/2006/main">
             <a:r>
-              <a:t>- editorial-forest.pptx — user-supplied visual reference.</a:t>
-            </a:r>
-          </a:p>
-          <a:p xmlns:a="http://schemas.openxmlformats.org/drawingml/2006/main">
-            <a:r>
-              <a:t>- make-something-strange-creative-mode(1).pptx — user-supplied editable layout reference.</a:t>
-            </a:r>
-          </a:p>
-          <a:p xmlns:a="http://schemas.openxmlformats.org/drawingml/2006/main">
-            <a:r>
-              <a:t>- https://github.com/zarazhangrui/beautiful-html-templates/blob/main/templates/editorial-forest/design.md — Editorial Forest typography and layout specification.</a:t>
-            </a:r>
-          </a:p>
-          <a:p xmlns:a="http://schemas.openxmlformats.org/drawingml/2006/main">
-            <a:r>
-              <a:t>- 4106acdf-6ce8-4dae-8708-0a996b804717.png — user-supplied five-topic bento reference.</a:t>
+              <a:t>- editorial-forest.pptx</a:t>
+            </a:r>
+          </a:p>
+          <a:p xmlns:a="http://schemas.openxmlformats.org/drawingml/2006/main">
+            <a:r>
+              <a:t>- make-something-strange-creative-mode(1).pptx</a:t>
+            </a:r>
+          </a:p>
+          <a:p xmlns:a="http://schemas.openxmlformats.org/drawingml/2006/main">
+            <a:r>
+              <a:t>- https://github.com/zarazhangrui/frontend-slides</a:t>
+            </a:r>
+          </a:p>
+          <a:p xmlns:a="http://schemas.openxmlformats.org/drawingml/2006/main">
+            <a:r>
+              <a:t>- 4106acdf-6ce8-4dae-8708-0a996b804717.png</a:t>
             </a:r>
           </a:p>
           <a:p xmlns:a="http://schemas.openxmlformats.org/drawingml/2006/main">
@@ -925,12 +905,7 @@
           </a:p>
           <a:p xmlns:a="http://schemas.openxmlformats.org/drawingml/2006/main">
             <a:r>
-              <a:t/>
-            </a:r>
-          </a:p>
-          <a:p xmlns:a="http://schemas.openxmlformats.org/drawingml/2006/main">
-            <a:r>
-              <a:t>All figures and block conditions are illustrative editorial scenarios, not measured findings or forecasts. The native line chart compares illustrative connected and fragmented canopy scenarios.</a:t>
+              <a:t>Illustrative scenario data; not measured or forecast.</a:t>
             </a:r>
           </a:p>
         </p:txBody>
@@ -1005,22 +980,22 @@
           </a:p>
           <a:p xmlns:a="http://schemas.openxmlformats.org/drawingml/2006/main">
             <a:r>
-              <a:t>- editorial-forest.pptx — user-supplied visual reference.</a:t>
-            </a:r>
-          </a:p>
-          <a:p xmlns:a="http://schemas.openxmlformats.org/drawingml/2006/main">
-            <a:r>
-              <a:t>- make-something-strange-creative-mode(1).pptx — user-supplied editable layout reference.</a:t>
-            </a:r>
-          </a:p>
-          <a:p xmlns:a="http://schemas.openxmlformats.org/drawingml/2006/main">
-            <a:r>
-              <a:t>- https://github.com/zarazhangrui/beautiful-html-templates/blob/main/templates/editorial-forest/design.md — Editorial Forest typography and layout specification.</a:t>
-            </a:r>
-          </a:p>
-          <a:p xmlns:a="http://schemas.openxmlformats.org/drawingml/2006/main">
-            <a:r>
-              <a:t>- 4106acdf-6ce8-4dae-8708-0a996b804717.png — user-supplied five-topic bento reference.</a:t>
+              <a:t>- editorial-forest.pptx</a:t>
+            </a:r>
+          </a:p>
+          <a:p xmlns:a="http://schemas.openxmlformats.org/drawingml/2006/main">
+            <a:r>
+              <a:t>- make-something-strange-creative-mode(1).pptx</a:t>
+            </a:r>
+          </a:p>
+          <a:p xmlns:a="http://schemas.openxmlformats.org/drawingml/2006/main">
+            <a:r>
+              <a:t>- https://github.com/zarazhangrui/frontend-slides</a:t>
+            </a:r>
+          </a:p>
+          <a:p xmlns:a="http://schemas.openxmlformats.org/drawingml/2006/main">
+            <a:r>
+              <a:t>- 4106acdf-6ce8-4dae-8708-0a996b804717.png</a:t>
             </a:r>
           </a:p>
           <a:p xmlns:a="http://schemas.openxmlformats.org/drawingml/2006/main">
@@ -1030,12 +1005,7 @@
           </a:p>
           <a:p xmlns:a="http://schemas.openxmlformats.org/drawingml/2006/main">
             <a:r>
-              <a:t/>
-            </a:r>
-          </a:p>
-          <a:p xmlns:a="http://schemas.openxmlformats.org/drawingml/2006/main">
-            <a:r>
-              <a:t>All figures and block conditions are illustrative editorial scenarios, not measured findings or forecasts. The native clustered column chart uses illustrative peak-temperature scenarios.</a:t>
+              <a:t>Illustrative scenario data; not measured or forecast.</a:t>
             </a:r>
           </a:p>
         </p:txBody>
@@ -1110,22 +1080,22 @@
           </a:p>
           <a:p xmlns:a="http://schemas.openxmlformats.org/drawingml/2006/main">
             <a:r>
-              <a:t>- editorial-forest.pptx — user-supplied visual reference.</a:t>
-            </a:r>
-          </a:p>
-          <a:p xmlns:a="http://schemas.openxmlformats.org/drawingml/2006/main">
-            <a:r>
-              <a:t>- make-something-strange-creative-mode(1).pptx — user-supplied editable layout reference.</a:t>
-            </a:r>
-          </a:p>
-          <a:p xmlns:a="http://schemas.openxmlformats.org/drawingml/2006/main">
-            <a:r>
-              <a:t>- https://github.com/zarazhangrui/beautiful-html-templates/blob/main/templates/editorial-forest/design.md — Editorial Forest typography and layout specification.</a:t>
-            </a:r>
-          </a:p>
-          <a:p xmlns:a="http://schemas.openxmlformats.org/drawingml/2006/main">
-            <a:r>
-              <a:t>- 4106acdf-6ce8-4dae-8708-0a996b804717.png — user-supplied five-topic bento reference.</a:t>
+              <a:t>- editorial-forest.pptx</a:t>
+            </a:r>
+          </a:p>
+          <a:p xmlns:a="http://schemas.openxmlformats.org/drawingml/2006/main">
+            <a:r>
+              <a:t>- make-something-strange-creative-mode(1).pptx</a:t>
+            </a:r>
+          </a:p>
+          <a:p xmlns:a="http://schemas.openxmlformats.org/drawingml/2006/main">
+            <a:r>
+              <a:t>- https://github.com/zarazhangrui/frontend-slides</a:t>
+            </a:r>
+          </a:p>
+          <a:p xmlns:a="http://schemas.openxmlformats.org/drawingml/2006/main">
+            <a:r>
+              <a:t>- 4106acdf-6ce8-4dae-8708-0a996b804717.png</a:t>
             </a:r>
           </a:p>
           <a:p xmlns:a="http://schemas.openxmlformats.org/drawingml/2006/main">
@@ -1135,12 +1105,7 @@
           </a:p>
           <a:p xmlns:a="http://schemas.openxmlformats.org/drawingml/2006/main">
             <a:r>
-              <a:t/>
-            </a:r>
-          </a:p>
-          <a:p xmlns:a="http://schemas.openxmlformats.org/drawingml/2006/main">
-            <a:r>
-              <a:t>All figures and block conditions are illustrative editorial scenarios, not measured findings or forecasts. The neighborhood ledger remains a native editable PowerPoint table.</a:t>
+              <a:t>Illustrative scenario data; not measured or forecast.</a:t>
             </a:r>
           </a:p>
         </p:txBody>
@@ -1215,22 +1180,22 @@
           </a:p>
           <a:p xmlns:a="http://schemas.openxmlformats.org/drawingml/2006/main">
             <a:r>
-              <a:t>- editorial-forest.pptx — user-supplied visual reference.</a:t>
-            </a:r>
-          </a:p>
-          <a:p xmlns:a="http://schemas.openxmlformats.org/drawingml/2006/main">
-            <a:r>
-              <a:t>- make-something-strange-creative-mode(1).pptx — user-supplied editable layout reference.</a:t>
-            </a:r>
-          </a:p>
-          <a:p xmlns:a="http://schemas.openxmlformats.org/drawingml/2006/main">
-            <a:r>
-              <a:t>- https://github.com/zarazhangrui/beautiful-html-templates/blob/main/templates/editorial-forest/design.md — Editorial Forest typography and layout specification.</a:t>
-            </a:r>
-          </a:p>
-          <a:p xmlns:a="http://schemas.openxmlformats.org/drawingml/2006/main">
-            <a:r>
-              <a:t>- 4106acdf-6ce8-4dae-8708-0a996b804717.png — user-supplied five-topic bento reference.</a:t>
+              <a:t>- editorial-forest.pptx</a:t>
+            </a:r>
+          </a:p>
+          <a:p xmlns:a="http://schemas.openxmlformats.org/drawingml/2006/main">
+            <a:r>
+              <a:t>- make-something-strange-creative-mode(1).pptx</a:t>
+            </a:r>
+          </a:p>
+          <a:p xmlns:a="http://schemas.openxmlformats.org/drawingml/2006/main">
+            <a:r>
+              <a:t>- https://github.com/zarazhangrui/frontend-slides</a:t>
+            </a:r>
+          </a:p>
+          <a:p xmlns:a="http://schemas.openxmlformats.org/drawingml/2006/main">
+            <a:r>
+              <a:t>- 4106acdf-6ce8-4dae-8708-0a996b804717.png</a:t>
             </a:r>
           </a:p>
           <a:p xmlns:a="http://schemas.openxmlformats.org/drawingml/2006/main">
@@ -1240,12 +1205,7 @@
           </a:p>
           <a:p xmlns:a="http://schemas.openxmlformats.org/drawingml/2006/main">
             <a:r>
-              <a:t/>
-            </a:r>
-          </a:p>
-          <a:p xmlns:a="http://schemas.openxmlformats.org/drawingml/2006/main">
-            <a:r>
-              <a:t>All figures and block conditions are illustrative editorial scenarios, not measured findings or forecasts. The closer mirrors the Editorial Forest cover anatomy at closing scale: one green field, a single oversized serif statement, a monogram circle, and one aligned footline.</a:t>
+              <a:t>Illustrative scenario data; not measured or forecast.</a:t>
             </a:r>
           </a:p>
         </p:txBody>
@@ -1313,7 +1273,7 @@
   </p:cSld>
   <p:clrMap bg1="lt1" tx1="dk1" bg2="lt2" tx2="dk2" accent1="accent1" accent2="accent2" accent3="accent3" accent4="accent4" accent5="accent5" accent6="accent6" hlink="hlink" folHlink="folHlink"/>
   <p:sldLayoutIdLst>
-    <p:sldLayoutId xmlns:r="http://schemas.openxmlformats.org/officeDocument/2006/relationships" id="2147483649" r:id="Re5cfae4a9d334fe4"/>
+    <p:sldLayoutId xmlns:r="http://schemas.openxmlformats.org/officeDocument/2006/relationships" id="2147483649" r:id="R81cc5e4afa944d6f"/>
   </p:sldLayoutIdLst>
   <p:txStyles>
     <p:titleStyle>
@@ -2611,7 +2571,7 @@
           <a:p xmlns:a="http://schemas.openxmlformats.org/drawingml/2006/main">
             <a:pPr algn="l">
               <a:buNone/>
-              <a:defRPr sz="900" b="0" i="0">
+              <a:defRPr sz="1125" b="0" i="0">
                 <a:solidFill>
                   <a:srgbClr val="E89CB1"/>
                 </a:solidFill>
@@ -2621,7 +2581,7 @@
               </a:defRPr>
             </a:pPr>
             <a:r>
-              <a:rPr sz="900" b="0" i="0">
+              <a:rPr sz="1125" b="0" i="0">
                 <a:solidFill>
                   <a:srgbClr val="E89CB1"/>
                 </a:solidFill>
@@ -2729,7 +2689,7 @@
           <a:p xmlns:a="http://schemas.openxmlformats.org/drawingml/2006/main">
             <a:pPr algn="l">
               <a:buNone/>
-              <a:defRPr sz="750" b="0" i="0">
+              <a:defRPr sz="900" b="0" i="0">
                 <a:solidFill>
                   <a:srgbClr val="E89CB1"/>
                 </a:solidFill>
@@ -2739,7 +2699,7 @@
               </a:defRPr>
             </a:pPr>
             <a:r>
-              <a:rPr sz="750" b="0" i="0">
+              <a:rPr sz="900" b="0" i="0">
                 <a:solidFill>
                   <a:srgbClr val="E89CB1"/>
                 </a:solidFill>
@@ -2997,7 +2957,7 @@
           <a:p xmlns:a="http://schemas.openxmlformats.org/drawingml/2006/main">
             <a:pPr algn="ctr">
               <a:buNone/>
-              <a:defRPr sz="1050" b="0" i="0">
+              <a:defRPr sz="1125" b="0" i="0">
                 <a:solidFill>
                   <a:srgbClr val="E89CB1"/>
                 </a:solidFill>
@@ -3007,7 +2967,7 @@
               </a:defRPr>
             </a:pPr>
             <a:r>
-              <a:rPr sz="1050" b="0" i="0">
+              <a:rPr sz="1125" b="0" i="0">
                 <a:solidFill>
                   <a:srgbClr val="E89CB1"/>
                 </a:solidFill>
@@ -3320,7 +3280,7 @@
           <a:p xmlns:a="http://schemas.openxmlformats.org/drawingml/2006/main">
             <a:pPr algn="r">
               <a:buNone/>
-              <a:defRPr sz="750" b="0" i="0">
+              <a:defRPr sz="900" b="0" i="0">
                 <a:solidFill>
                   <a:srgbClr val="E89CB1"/>
                 </a:solidFill>
@@ -3330,7 +3290,7 @@
               </a:defRPr>
             </a:pPr>
             <a:r>
-              <a:rPr sz="750" b="0" i="0">
+              <a:rPr sz="900" b="0" i="0">
                 <a:solidFill>
                   <a:srgbClr val="E89CB1"/>
                 </a:solidFill>
@@ -3408,7 +3368,7 @@
           <a:p xmlns:a="http://schemas.openxmlformats.org/drawingml/2006/main">
             <a:pPr algn="r">
               <a:buNone/>
-              <a:defRPr sz="900" b="0" i="0">
+              <a:defRPr sz="1050" b="0" i="0">
                 <a:solidFill>
                   <a:srgbClr val="2E4A2A"/>
                 </a:solidFill>
@@ -3418,7 +3378,7 @@
               </a:defRPr>
             </a:pPr>
             <a:r>
-              <a:rPr sz="900" b="0" i="0">
+              <a:rPr sz="1050" b="0" i="0">
                 <a:solidFill>
                   <a:srgbClr val="2E4A2A"/>
                 </a:solidFill>
@@ -3467,7 +3427,7 @@
           <a:p xmlns:a="http://schemas.openxmlformats.org/drawingml/2006/main">
             <a:pPr algn="r">
               <a:buNone/>
-              <a:defRPr sz="675" b="0" i="0">
+              <a:defRPr sz="825" b="0" i="0">
                 <a:solidFill>
                   <a:srgbClr val="2E4A2A"/>
                 </a:solidFill>
@@ -3477,7 +3437,7 @@
               </a:defRPr>
             </a:pPr>
             <a:r>
-              <a:rPr sz="675" b="0" i="0">
+              <a:rPr sz="825" b="0" i="0">
                 <a:solidFill>
                   <a:srgbClr val="2E4A2A"/>
                 </a:solidFill>
@@ -3526,7 +3486,7 @@
           <a:p xmlns:a="http://schemas.openxmlformats.org/drawingml/2006/main">
             <a:pPr algn="l">
               <a:buNone/>
-              <a:defRPr sz="675" b="0" i="0">
+              <a:defRPr sz="825" b="0" i="0">
                 <a:solidFill>
                   <a:srgbClr val="2E4A2A"/>
                 </a:solidFill>
@@ -3536,7 +3496,7 @@
               </a:defRPr>
             </a:pPr>
             <a:r>
-              <a:rPr sz="675" b="0" i="0">
+              <a:rPr sz="825" b="0" i="0">
                 <a:solidFill>
                   <a:srgbClr val="2E4A2A"/>
                 </a:solidFill>
@@ -3717,7 +3677,7 @@
           <a:p xmlns:a="http://schemas.openxmlformats.org/drawingml/2006/main">
             <a:pPr algn="l">
               <a:buNone/>
-              <a:defRPr sz="1050" b="0" i="0">
+              <a:defRPr sz="1200" b="0" i="0">
                 <a:solidFill>
                   <a:srgbClr val="E89CB1"/>
                 </a:solidFill>
@@ -3727,7 +3687,7 @@
               </a:defRPr>
             </a:pPr>
             <a:r>
-              <a:rPr sz="1050" b="0" i="0">
+              <a:rPr sz="1200" b="0" i="0">
                 <a:solidFill>
                   <a:srgbClr val="E89CB1"/>
                 </a:solidFill>
@@ -3779,7 +3739,7 @@
                 <a:spcPct val="98000"/>
               </a:lnSpc>
               <a:buNone/>
-              <a:defRPr sz="3150" b="0" i="0">
+              <a:defRPr sz="3600" b="0" i="0">
                 <a:solidFill>
                   <a:srgbClr val="E89CB1"/>
                 </a:solidFill>
@@ -3789,7 +3749,7 @@
               </a:defRPr>
             </a:pPr>
             <a:r>
-              <a:rPr sz="3150" b="0" i="0">
+              <a:rPr sz="3600" b="0" i="0">
                 <a:solidFill>
                   <a:srgbClr val="E89CB1"/>
                 </a:solidFill>
@@ -3806,7 +3766,7 @@
                 <a:spcPct val="98000"/>
               </a:lnSpc>
               <a:buNone/>
-              <a:defRPr sz="3150" b="0" i="0">
+              <a:defRPr sz="3600" b="0" i="0">
                 <a:solidFill>
                   <a:srgbClr val="E89CB1"/>
                 </a:solidFill>
@@ -3816,7 +3776,7 @@
               </a:defRPr>
             </a:pPr>
             <a:r>
-              <a:rPr sz="3150" b="0" i="0">
+              <a:rPr sz="3600" b="0" i="0">
                 <a:solidFill>
                   <a:srgbClr val="E89CB1"/>
                 </a:solidFill>
@@ -3824,7 +3784,34 @@
                 <a:ea typeface="Source Serif 4 Medium"/>
                 <a:cs typeface="Source Serif 4 Medium"/>
               </a:rPr>
-              <a:t>loses connection.</a:t>
+              <a:t>loses</a:t>
+            </a:r>
+          </a:p>
+          <a:p xmlns:a="http://schemas.openxmlformats.org/drawingml/2006/main">
+            <a:pPr algn="l">
+              <a:lnSpc>
+                <a:spcPct val="98000"/>
+              </a:lnSpc>
+              <a:buNone/>
+              <a:defRPr sz="3600" b="0" i="0">
+                <a:solidFill>
+                  <a:srgbClr val="E89CB1"/>
+                </a:solidFill>
+                <a:latin typeface="Source Serif 4 Medium"/>
+                <a:ea typeface="Source Serif 4 Medium"/>
+                <a:cs typeface="Source Serif 4 Medium"/>
+              </a:defRPr>
+            </a:pPr>
+            <a:r>
+              <a:rPr sz="3600" b="0" i="0">
+                <a:solidFill>
+                  <a:srgbClr val="E89CB1"/>
+                </a:solidFill>
+                <a:latin typeface="Source Serif 4 Medium"/>
+                <a:ea typeface="Source Serif 4 Medium"/>
+                <a:cs typeface="Source Serif 4 Medium"/>
+              </a:rPr>
+              <a:t>connection.</a:t>
             </a:r>
           </a:p>
         </p:txBody>
@@ -3894,7 +3881,7 @@
           <a:p xmlns:a="http://schemas.openxmlformats.org/drawingml/2006/main">
             <a:pPr algn="l">
               <a:buNone/>
-              <a:defRPr sz="900" b="0" i="0">
+              <a:defRPr sz="1050" b="0" i="0">
                 <a:solidFill>
                   <a:srgbClr val="E89CB1"/>
                 </a:solidFill>
@@ -3904,7 +3891,7 @@
               </a:defRPr>
             </a:pPr>
             <a:r>
-              <a:rPr sz="900" b="0" i="0">
+              <a:rPr sz="1050" b="0" i="0">
                 <a:solidFill>
                   <a:srgbClr val="E89CB1"/>
                 </a:solidFill>
@@ -3952,7 +3939,7 @@
           <a:lstStyle xmlns:a="http://schemas.openxmlformats.org/drawingml/2006/main"/>
           <a:p xmlns:a="http://schemas.openxmlformats.org/drawingml/2006/main">
             <a:pPr algn="l">
-              <a:defRPr sz="1050" b="0">
+              <a:defRPr sz="1200" b="0">
                 <a:solidFill>
                   <a:srgbClr val="243A21"/>
                 </a:solidFill>
@@ -3962,7 +3949,7 @@
               </a:defRPr>
             </a:pPr>
             <a:r>
-              <a:rPr sz="1050" b="0">
+              <a:rPr sz="1200" b="0">
                 <a:solidFill>
                   <a:srgbClr val="243A21"/>
                 </a:solidFill>
@@ -4046,7 +4033,7 @@
           <a:p xmlns:a="http://schemas.openxmlformats.org/drawingml/2006/main">
             <a:pPr algn="l">
               <a:buNone/>
-              <a:defRPr sz="1050" b="0" i="0">
+              <a:defRPr sz="1200" b="0" i="0">
                 <a:solidFill>
                   <a:srgbClr val="243A21"/>
                 </a:solidFill>
@@ -4056,7 +4043,7 @@
               </a:defRPr>
             </a:pPr>
             <a:r>
-              <a:rPr sz="1050" b="0" i="0">
+              <a:rPr sz="1200" b="0" i="0">
                 <a:solidFill>
                   <a:srgbClr val="243A21"/>
                 </a:solidFill>
@@ -4108,7 +4095,7 @@
                 <a:spcPct val="98000"/>
               </a:lnSpc>
               <a:buNone/>
-              <a:defRPr sz="2250" b="0" i="0">
+              <a:defRPr sz="2925" b="0" i="0">
                 <a:solidFill>
                   <a:srgbClr val="243A21"/>
                 </a:solidFill>
@@ -4118,7 +4105,7 @@
               </a:defRPr>
             </a:pPr>
             <a:r>
-              <a:rPr sz="2250" b="0" i="0">
+              <a:rPr sz="2925" b="0" i="0">
                 <a:solidFill>
                   <a:srgbClr val="243A21"/>
                 </a:solidFill>
@@ -4126,7 +4113,7 @@
                 <a:ea typeface="Source Serif 4 Medium"/>
                 <a:cs typeface="Source Serif 4 Medium"/>
               </a:rPr>
-              <a:t>Four connected</a:t>
+              <a:t>Four linked</a:t>
             </a:r>
           </a:p>
           <a:p xmlns:a="http://schemas.openxmlformats.org/drawingml/2006/main">
@@ -4135,7 +4122,7 @@
                 <a:spcPct val="98000"/>
               </a:lnSpc>
               <a:buNone/>
-              <a:defRPr sz="2250" b="0" i="0">
+              <a:defRPr sz="2925" b="0" i="0">
                 <a:solidFill>
                   <a:srgbClr val="243A21"/>
                 </a:solidFill>
@@ -4145,7 +4132,7 @@
               </a:defRPr>
             </a:pPr>
             <a:r>
-              <a:rPr sz="2250" b="0" i="0">
+              <a:rPr sz="2925" b="0" i="0">
                 <a:solidFill>
                   <a:srgbClr val="243A21"/>
                 </a:solidFill>
@@ -4223,7 +4210,7 @@
           <a:p xmlns:a="http://schemas.openxmlformats.org/drawingml/2006/main">
             <a:pPr algn="l">
               <a:buNone/>
-              <a:defRPr sz="900" b="0" i="0">
+              <a:defRPr sz="1050" b="0" i="0">
                 <a:solidFill>
                   <a:srgbClr val="243A21"/>
                 </a:solidFill>
@@ -4233,7 +4220,7 @@
               </a:defRPr>
             </a:pPr>
             <a:r>
-              <a:rPr sz="900" b="0" i="0">
+              <a:rPr sz="1050" b="0" i="0">
                 <a:solidFill>
                   <a:srgbClr val="243A21"/>
                 </a:solidFill>
@@ -4285,7 +4272,7 @@
                 <a:spcPct val="98000"/>
               </a:lnSpc>
               <a:buNone/>
-              <a:defRPr sz="2325" b="0">
+              <a:defRPr sz="2925" b="0">
                 <a:solidFill>
                   <a:srgbClr val="243A21"/>
                 </a:solidFill>
@@ -4295,7 +4282,7 @@
               </a:defRPr>
             </a:pPr>
             <a:r>
-              <a:rPr sz="2325" b="0">
+              <a:rPr sz="2925" b="0">
                 <a:solidFill>
                   <a:srgbClr val="243A21"/>
                 </a:solidFill>
@@ -4303,7 +4290,34 @@
                 <a:ea typeface="Source Serif 4 Medium"/>
                 <a:cs typeface="Source Serif 4 Medium"/>
               </a:rPr>
-              <a:t>Block actions.</a:t>
+              <a:t>Block</a:t>
+            </a:r>
+          </a:p>
+          <a:p xmlns:a="http://schemas.openxmlformats.org/drawingml/2006/main">
+            <a:pPr algn="l">
+              <a:lnSpc>
+                <a:spcPct val="98000"/>
+              </a:lnSpc>
+              <a:buNone/>
+              <a:defRPr sz="2925" b="0">
+                <a:solidFill>
+                  <a:srgbClr val="243A21"/>
+                </a:solidFill>
+                <a:latin typeface="Source Serif 4 Medium"/>
+                <a:ea typeface="Source Serif 4 Medium"/>
+                <a:cs typeface="Source Serif 4 Medium"/>
+              </a:defRPr>
+            </a:pPr>
+            <a:r>
+              <a:rPr sz="2925" b="0">
+                <a:solidFill>
+                  <a:srgbClr val="243A21"/>
+                </a:solidFill>
+                <a:latin typeface="Source Serif 4 Medium"/>
+                <a:ea typeface="Source Serif 4 Medium"/>
+                <a:cs typeface="Source Serif 4 Medium"/>
+              </a:rPr>
+              <a:t>actions.</a:t>
             </a:r>
           </a:p>
         </p:txBody>
@@ -4379,7 +4393,7 @@
           <a:p xmlns:a="http://schemas.openxmlformats.org/drawingml/2006/main">
             <a:pPr algn="l">
               <a:buNone/>
-              <a:defRPr sz="1050" b="0" i="0">
+              <a:defRPr sz="1200" b="0" i="0">
                 <a:solidFill>
                   <a:srgbClr val="2E4A2A"/>
                 </a:solidFill>
@@ -4389,7 +4403,7 @@
               </a:defRPr>
             </a:pPr>
             <a:r>
-              <a:rPr sz="1050" b="0" i="0">
+              <a:rPr sz="1200" b="0" i="0">
                 <a:solidFill>
                   <a:srgbClr val="2E4A2A"/>
                 </a:solidFill>
@@ -4441,7 +4455,7 @@
                 <a:spcPct val="98000"/>
               </a:lnSpc>
               <a:buNone/>
-              <a:defRPr sz="2325" b="0" i="0">
+              <a:defRPr sz="2925" b="0" i="0">
                 <a:solidFill>
                   <a:srgbClr val="2E4A2A"/>
                 </a:solidFill>
@@ -4451,7 +4465,7 @@
               </a:defRPr>
             </a:pPr>
             <a:r>
-              <a:rPr sz="2325" b="0" i="0">
+              <a:rPr sz="2925" b="0" i="0">
                 <a:solidFill>
                   <a:srgbClr val="2E4A2A"/>
                 </a:solidFill>
@@ -4459,7 +4473,34 @@
                 <a:ea typeface="Source Serif 4 Medium"/>
                 <a:cs typeface="Source Serif 4 Medium"/>
               </a:rPr>
-              <a:t>By the numbers.</a:t>
+              <a:t>By the</a:t>
+            </a:r>
+          </a:p>
+          <a:p xmlns:a="http://schemas.openxmlformats.org/drawingml/2006/main">
+            <a:pPr algn="l">
+              <a:lnSpc>
+                <a:spcPct val="98000"/>
+              </a:lnSpc>
+              <a:buNone/>
+              <a:defRPr sz="2925" b="0" i="0">
+                <a:solidFill>
+                  <a:srgbClr val="2E4A2A"/>
+                </a:solidFill>
+                <a:latin typeface="Source Serif 4 Medium"/>
+                <a:ea typeface="Source Serif 4 Medium"/>
+                <a:cs typeface="Source Serif 4 Medium"/>
+              </a:defRPr>
+            </a:pPr>
+            <a:r>
+              <a:rPr sz="2925" b="0" i="0">
+                <a:solidFill>
+                  <a:srgbClr val="2E4A2A"/>
+                </a:solidFill>
+                <a:latin typeface="Source Serif 4 Medium"/>
+                <a:ea typeface="Source Serif 4 Medium"/>
+                <a:cs typeface="Source Serif 4 Medium"/>
+              </a:rPr>
+              <a:t>numbers.</a:t>
             </a:r>
           </a:p>
         </p:txBody>
@@ -4529,7 +4570,7 @@
           <a:p xmlns:a="http://schemas.openxmlformats.org/drawingml/2006/main">
             <a:pPr algn="l">
               <a:buNone/>
-              <a:defRPr sz="900" b="0" i="0">
+              <a:defRPr sz="1050" b="0" i="0">
                 <a:solidFill>
                   <a:srgbClr val="2E4A2A"/>
                 </a:solidFill>
@@ -4539,7 +4580,7 @@
               </a:defRPr>
             </a:pPr>
             <a:r>
-              <a:rPr sz="900" b="0" i="0">
+              <a:rPr sz="1050" b="0" i="0">
                 <a:solidFill>
                   <a:srgbClr val="2E4A2A"/>
                 </a:solidFill>
@@ -4587,7 +4628,7 @@
           <a:lstStyle xmlns:a="http://schemas.openxmlformats.org/drawingml/2006/main"/>
           <a:p xmlns:a="http://schemas.openxmlformats.org/drawingml/2006/main">
             <a:pPr algn="l">
-              <a:defRPr sz="900" b="0">
+              <a:defRPr sz="1050" b="0">
                 <a:solidFill>
                   <a:srgbClr val="243A21"/>
                 </a:solidFill>
@@ -4597,7 +4638,7 @@
               </a:defRPr>
             </a:pPr>
             <a:r>
-              <a:rPr sz="900" b="0">
+              <a:rPr sz="1050" b="0">
                 <a:solidFill>
                   <a:srgbClr val="243A21"/>
                 </a:solidFill>
@@ -4681,7 +4722,7 @@
           <a:p xmlns:a="http://schemas.openxmlformats.org/drawingml/2006/main">
             <a:pPr algn="l">
               <a:buNone/>
-              <a:defRPr sz="1050" b="0" i="0">
+              <a:defRPr sz="1200" b="0" i="0">
                 <a:solidFill>
                   <a:srgbClr val="E89CB1"/>
                 </a:solidFill>
@@ -4691,7 +4732,7 @@
               </a:defRPr>
             </a:pPr>
             <a:r>
-              <a:rPr sz="1050" b="0" i="0">
+              <a:rPr sz="1200" b="0" i="0">
                 <a:solidFill>
                   <a:srgbClr val="E89CB1"/>
                 </a:solidFill>
@@ -4743,7 +4784,7 @@
                 <a:spcPct val="98000"/>
               </a:lnSpc>
               <a:buNone/>
-              <a:defRPr sz="2325" b="0" i="0">
+              <a:defRPr sz="2925" b="0" i="0">
                 <a:solidFill>
                   <a:srgbClr val="E89CB1"/>
                 </a:solidFill>
@@ -4753,7 +4794,7 @@
               </a:defRPr>
             </a:pPr>
             <a:r>
-              <a:rPr sz="2325" b="0" i="0">
+              <a:rPr sz="2925" b="0" i="0">
                 <a:solidFill>
                   <a:srgbClr val="E89CB1"/>
                 </a:solidFill>
@@ -4770,7 +4811,7 @@
                 <a:spcPct val="98000"/>
               </a:lnSpc>
               <a:buNone/>
-              <a:defRPr sz="2325" b="0" i="0">
+              <a:defRPr sz="2925" b="0" i="0">
                 <a:solidFill>
                   <a:srgbClr val="E89CB1"/>
                 </a:solidFill>
@@ -4780,7 +4821,7 @@
               </a:defRPr>
             </a:pPr>
             <a:r>
-              <a:rPr sz="2325" b="0" i="0">
+              <a:rPr sz="2925" b="0" i="0">
                 <a:solidFill>
                   <a:srgbClr val="E89CB1"/>
                 </a:solidFill>
@@ -4858,7 +4899,7 @@
           <a:p xmlns:a="http://schemas.openxmlformats.org/drawingml/2006/main">
             <a:pPr algn="l">
               <a:buNone/>
-              <a:defRPr sz="900" b="0" i="0">
+              <a:defRPr sz="1050" b="0" i="0">
                 <a:solidFill>
                   <a:srgbClr val="E89CB1"/>
                 </a:solidFill>
@@ -4868,7 +4909,7 @@
               </a:defRPr>
             </a:pPr>
             <a:r>
-              <a:rPr sz="900" b="0" i="0">
+              <a:rPr sz="1050" b="0" i="0">
                 <a:solidFill>
                   <a:srgbClr val="E89CB1"/>
                 </a:solidFill>
@@ -4946,7 +4987,7 @@
           <a:p xmlns:a="http://schemas.openxmlformats.org/drawingml/2006/main">
             <a:pPr algn="l">
               <a:buNone/>
-              <a:defRPr sz="900" b="0" i="0">
+              <a:defRPr sz="1050" b="0" i="0">
                 <a:solidFill>
                   <a:srgbClr val="243A21"/>
                 </a:solidFill>
@@ -4956,7 +4997,7 @@
               </a:defRPr>
             </a:pPr>
             <a:r>
-              <a:rPr sz="900" b="0" i="0">
+              <a:rPr sz="1050" b="0" i="0">
                 <a:solidFill>
                   <a:srgbClr val="243A21"/>
                 </a:solidFill>
@@ -5005,7 +5046,7 @@
           <a:p xmlns:a="http://schemas.openxmlformats.org/drawingml/2006/main">
             <a:pPr algn="r">
               <a:buNone/>
-              <a:defRPr sz="900" b="0" i="0">
+              <a:defRPr sz="1050" b="0" i="0">
                 <a:solidFill>
                   <a:srgbClr val="243A21"/>
                 </a:solidFill>
@@ -5015,7 +5056,7 @@
               </a:defRPr>
             </a:pPr>
             <a:r>
-              <a:rPr sz="900" b="0" i="0">
+              <a:rPr sz="1050" b="0" i="0">
                 <a:solidFill>
                   <a:srgbClr val="243A21"/>
                 </a:solidFill>
@@ -5064,7 +5105,7 @@
           <a:p xmlns:a="http://schemas.openxmlformats.org/drawingml/2006/main">
             <a:pPr algn="r">
               <a:buNone/>
-              <a:defRPr sz="750" b="0" i="0">
+              <a:defRPr sz="825" b="0" i="0">
                 <a:solidFill>
                   <a:srgbClr val="243A21"/>
                 </a:solidFill>
@@ -5074,7 +5115,7 @@
               </a:defRPr>
             </a:pPr>
             <a:r>
-              <a:rPr sz="750" b="0" i="0">
+              <a:rPr sz="825" b="0" i="0">
                 <a:solidFill>
                   <a:srgbClr val="243A21"/>
                 </a:solidFill>
@@ -5655,7 +5696,7 @@
           <a:p xmlns:a="http://schemas.openxmlformats.org/drawingml/2006/main">
             <a:pPr algn="l">
               <a:buNone/>
-              <a:defRPr sz="750" b="0" i="0">
+              <a:defRPr sz="825" b="0" i="0">
                 <a:solidFill>
                   <a:srgbClr val="243A21"/>
                 </a:solidFill>
@@ -5665,7 +5706,7 @@
               </a:defRPr>
             </a:pPr>
             <a:r>
-              <a:rPr sz="750" b="0" i="0">
+              <a:rPr sz="825" b="0" i="0">
                 <a:solidFill>
                   <a:srgbClr val="243A21"/>
                 </a:solidFill>
@@ -5743,7 +5784,7 @@
           <a:p xmlns:a="http://schemas.openxmlformats.org/drawingml/2006/main">
             <a:pPr algn="l">
               <a:buNone/>
-              <a:defRPr sz="900" b="0" i="0">
+              <a:defRPr sz="1050" b="0" i="0">
                 <a:solidFill>
                   <a:srgbClr val="2E4A2A"/>
                 </a:solidFill>
@@ -5753,7 +5794,7 @@
               </a:defRPr>
             </a:pPr>
             <a:r>
-              <a:rPr sz="900" b="0" i="0">
+              <a:rPr sz="1050" b="0" i="0">
                 <a:solidFill>
                   <a:srgbClr val="2E4A2A"/>
                 </a:solidFill>
@@ -5802,7 +5843,7 @@
           <a:p xmlns:a="http://schemas.openxmlformats.org/drawingml/2006/main">
             <a:pPr algn="r">
               <a:buNone/>
-              <a:defRPr sz="900" b="0" i="0">
+              <a:defRPr sz="1050" b="0" i="0">
                 <a:solidFill>
                   <a:srgbClr val="2E4A2A"/>
                 </a:solidFill>
@@ -5812,7 +5853,7 @@
               </a:defRPr>
             </a:pPr>
             <a:r>
-              <a:rPr sz="900" b="0" i="0">
+              <a:rPr sz="1050" b="0" i="0">
                 <a:solidFill>
                   <a:srgbClr val="2E4A2A"/>
                 </a:solidFill>
@@ -5861,7 +5902,7 @@
           <a:p xmlns:a="http://schemas.openxmlformats.org/drawingml/2006/main">
             <a:pPr algn="l">
               <a:buNone/>
-              <a:defRPr sz="675" b="0" i="0">
+              <a:defRPr sz="825" b="0" i="0">
                 <a:solidFill>
                   <a:srgbClr val="2E4A2A"/>
                 </a:solidFill>
@@ -5871,7 +5912,7 @@
               </a:defRPr>
             </a:pPr>
             <a:r>
-              <a:rPr sz="675" b="0" i="0">
+              <a:rPr sz="825" b="0" i="0">
                 <a:solidFill>
                   <a:srgbClr val="2E4A2A"/>
                 </a:solidFill>
@@ -6906,7 +6947,7 @@
           <a:p xmlns:a="http://schemas.openxmlformats.org/drawingml/2006/main">
             <a:pPr algn="l">
               <a:buNone/>
-              <a:defRPr sz="900" b="0" i="0">
+              <a:defRPr sz="1050" b="0" i="0">
                 <a:solidFill>
                   <a:srgbClr val="E89CB1"/>
                 </a:solidFill>
@@ -6916,7 +6957,7 @@
               </a:defRPr>
             </a:pPr>
             <a:r>
-              <a:rPr sz="900" b="0" i="0">
+              <a:rPr sz="1050" b="0" i="0">
                 <a:solidFill>
                   <a:srgbClr val="E89CB1"/>
                 </a:solidFill>
@@ -6965,7 +7006,7 @@
           <a:p xmlns:a="http://schemas.openxmlformats.org/drawingml/2006/main">
             <a:pPr algn="r">
               <a:buNone/>
-              <a:defRPr sz="900" b="0" i="0">
+              <a:defRPr sz="1050" b="0" i="0">
                 <a:solidFill>
                   <a:srgbClr val="E89CB1"/>
                 </a:solidFill>
@@ -6975,7 +7016,7 @@
               </a:defRPr>
             </a:pPr>
             <a:r>
-              <a:rPr sz="900" b="0" i="0">
+              <a:rPr sz="1050" b="0" i="0">
                 <a:solidFill>
                   <a:srgbClr val="E89CB1"/>
                 </a:solidFill>
@@ -7024,7 +7065,7 @@
           <a:p xmlns:a="http://schemas.openxmlformats.org/drawingml/2006/main">
             <a:pPr algn="l">
               <a:buNone/>
-              <a:defRPr sz="675" b="0" i="0">
+              <a:defRPr sz="825" b="0" i="0">
                 <a:solidFill>
                   <a:srgbClr val="E89CB1"/>
                 </a:solidFill>
@@ -7034,7 +7075,7 @@
               </a:defRPr>
             </a:pPr>
             <a:r>
-              <a:rPr sz="675" b="0" i="0">
+              <a:rPr sz="825" b="0" i="0">
                 <a:solidFill>
                   <a:srgbClr val="E89CB1"/>
                 </a:solidFill>
@@ -7214,7 +7255,7 @@
         </p:xfrm>
         <a:graphic xmlns:a="http://schemas.openxmlformats.org/drawingml/2006/main">
           <a:graphicData uri="http://schemas.openxmlformats.org/drawingml/2006/chart">
-            <c:chart xmlns:r="http://schemas.openxmlformats.org/officeDocument/2006/relationships" xmlns:c="http://schemas.openxmlformats.org/drawingml/2006/chart" r:id="Rd02e2c593b694dda"/>
+            <c:chart xmlns:r="http://schemas.openxmlformats.org/officeDocument/2006/relationships" xmlns:c="http://schemas.openxmlformats.org/drawingml/2006/chart" r:id="Rb034870992cc4a2d"/>
           </a:graphicData>
         </a:graphic>
       </p:graphicFrame>
@@ -7586,7 +7627,7 @@
           <a:p xmlns:a="http://schemas.openxmlformats.org/drawingml/2006/main">
             <a:pPr algn="l">
               <a:buNone/>
-              <a:defRPr sz="900" b="0" i="0">
+              <a:defRPr sz="1050" b="0" i="0">
                 <a:solidFill>
                   <a:srgbClr val="2E4A2A"/>
                 </a:solidFill>
@@ -7596,7 +7637,7 @@
               </a:defRPr>
             </a:pPr>
             <a:r>
-              <a:rPr sz="900" b="0" i="0">
+              <a:rPr sz="1050" b="0" i="0">
                 <a:solidFill>
                   <a:srgbClr val="2E4A2A"/>
                 </a:solidFill>
@@ -7645,7 +7686,7 @@
           <a:p xmlns:a="http://schemas.openxmlformats.org/drawingml/2006/main">
             <a:pPr algn="r">
               <a:buNone/>
-              <a:defRPr sz="900" b="0" i="0">
+              <a:defRPr sz="1050" b="0" i="0">
                 <a:solidFill>
                   <a:srgbClr val="2E4A2A"/>
                 </a:solidFill>
@@ -7655,7 +7696,7 @@
               </a:defRPr>
             </a:pPr>
             <a:r>
-              <a:rPr sz="900" b="0" i="0">
+              <a:rPr sz="1050" b="0" i="0">
                 <a:solidFill>
                   <a:srgbClr val="2E4A2A"/>
                 </a:solidFill>
@@ -7704,7 +7745,7 @@
           <a:p xmlns:a="http://schemas.openxmlformats.org/drawingml/2006/main">
             <a:pPr algn="l">
               <a:buNone/>
-              <a:defRPr sz="675" b="0" i="0">
+              <a:defRPr sz="825" b="0" i="0">
                 <a:solidFill>
                   <a:srgbClr val="2E4A2A"/>
                 </a:solidFill>
@@ -7714,7 +7755,7 @@
               </a:defRPr>
             </a:pPr>
             <a:r>
-              <a:rPr sz="675" b="0" i="0">
+              <a:rPr sz="825" b="0" i="0">
                 <a:solidFill>
                   <a:srgbClr val="2E4A2A"/>
                 </a:solidFill>
@@ -7894,7 +7935,7 @@
         </p:xfrm>
         <a:graphic xmlns:a="http://schemas.openxmlformats.org/drawingml/2006/main">
           <a:graphicData uri="http://schemas.openxmlformats.org/drawingml/2006/chart">
-            <c:chart xmlns:r="http://schemas.openxmlformats.org/officeDocument/2006/relationships" xmlns:c="http://schemas.openxmlformats.org/drawingml/2006/chart" r:id="Race6706c74d5462b"/>
+            <c:chart xmlns:r="http://schemas.openxmlformats.org/officeDocument/2006/relationships" xmlns:c="http://schemas.openxmlformats.org/drawingml/2006/chart" r:id="R29a2c6f8519941b4"/>
           </a:graphicData>
         </a:graphic>
       </p:graphicFrame>
@@ -8298,7 +8339,7 @@
           <a:p xmlns:a="http://schemas.openxmlformats.org/drawingml/2006/main">
             <a:pPr algn="l">
               <a:buNone/>
-              <a:defRPr sz="900" b="0" i="0">
+              <a:defRPr sz="1050" b="0" i="0">
                 <a:solidFill>
                   <a:srgbClr val="2E4A2A"/>
                 </a:solidFill>
@@ -8308,7 +8349,7 @@
               </a:defRPr>
             </a:pPr>
             <a:r>
-              <a:rPr sz="900" b="0" i="0">
+              <a:rPr sz="1050" b="0" i="0">
                 <a:solidFill>
                   <a:srgbClr val="2E4A2A"/>
                 </a:solidFill>
@@ -8357,7 +8398,7 @@
           <a:p xmlns:a="http://schemas.openxmlformats.org/drawingml/2006/main">
             <a:pPr algn="r">
               <a:buNone/>
-              <a:defRPr sz="900" b="0" i="0">
+              <a:defRPr sz="1050" b="0" i="0">
                 <a:solidFill>
                   <a:srgbClr val="2E4A2A"/>
                 </a:solidFill>
@@ -8367,7 +8408,7 @@
               </a:defRPr>
             </a:pPr>
             <a:r>
-              <a:rPr sz="900" b="0" i="0">
+              <a:rPr sz="1050" b="0" i="0">
                 <a:solidFill>
                   <a:srgbClr val="2E4A2A"/>
                 </a:solidFill>
@@ -8416,7 +8457,7 @@
           <a:p xmlns:a="http://schemas.openxmlformats.org/drawingml/2006/main">
             <a:pPr algn="l">
               <a:buNone/>
-              <a:defRPr sz="675" b="0" i="0">
+              <a:defRPr sz="825" b="0" i="0">
                 <a:solidFill>
                   <a:srgbClr val="2E4A2A"/>
                 </a:solidFill>
@@ -8426,7 +8467,7 @@
               </a:defRPr>
             </a:pPr>
             <a:r>
-              <a:rPr sz="675" b="0" i="0">
+              <a:rPr sz="825" b="0" i="0">
                 <a:solidFill>
                   <a:srgbClr val="2E4A2A"/>
                 </a:solidFill>
@@ -8469,7 +8510,7 @@
         </p:spPr>
         <p:txBody>
           <a:bodyPr xmlns:a="http://schemas.openxmlformats.org/drawingml/2006/main" wrap="square" lIns="0" tIns="0" rIns="0" bIns="0" anchor="t">
-            <a:normAutofit fontScale="93684"/>
+            <a:normAutofit fontScale="100000"/>
           </a:bodyPr>
           <a:lstStyle xmlns:a="http://schemas.openxmlformats.org/drawingml/2006/main"/>
           <a:p xmlns:a="http://schemas.openxmlformats.org/drawingml/2006/main">
@@ -9243,7 +9284,7 @@
           <a:p xmlns:a="http://schemas.openxmlformats.org/drawingml/2006/main">
             <a:pPr algn="l">
               <a:buNone/>
-              <a:defRPr sz="900" b="0" i="0">
+              <a:defRPr sz="1050" b="0" i="0">
                 <a:solidFill>
                   <a:srgbClr val="E89CB1"/>
                 </a:solidFill>
@@ -9253,7 +9294,7 @@
               </a:defRPr>
             </a:pPr>
             <a:r>
-              <a:rPr sz="900" b="0" i="0">
+              <a:rPr sz="1050" b="0" i="0">
                 <a:solidFill>
                   <a:srgbClr val="E89CB1"/>
                 </a:solidFill>
@@ -9453,7 +9494,7 @@
           <a:p xmlns:a="http://schemas.openxmlformats.org/drawingml/2006/main">
             <a:pPr algn="l">
               <a:buNone/>
-              <a:defRPr sz="750" b="0" i="0">
+              <a:defRPr sz="900" b="0" i="0">
                 <a:solidFill>
                   <a:srgbClr val="E89CB1"/>
                 </a:solidFill>
@@ -9463,7 +9504,7 @@
               </a:defRPr>
             </a:pPr>
             <a:r>
-              <a:rPr sz="750" b="0" i="0">
+              <a:rPr sz="900" b="0" i="0">
                 <a:solidFill>
                   <a:srgbClr val="E89CB1"/>
                 </a:solidFill>
@@ -9543,7 +9584,7 @@
           <a:p xmlns:a="http://schemas.openxmlformats.org/drawingml/2006/main">
             <a:pPr algn="ctr">
               <a:buNone/>
-              <a:defRPr sz="1050" b="0" i="0">
+              <a:defRPr sz="1125" b="0" i="0">
                 <a:solidFill>
                   <a:srgbClr val="E89CB1"/>
                 </a:solidFill>
@@ -9553,7 +9594,7 @@
               </a:defRPr>
             </a:pPr>
             <a:r>
-              <a:rPr sz="1050" b="0" i="0">
+              <a:rPr sz="1125" b="0" i="0">
                 <a:solidFill>
                   <a:srgbClr val="E89CB1"/>
                 </a:solidFill>
@@ -9602,7 +9643,7 @@
           <a:p xmlns:a="http://schemas.openxmlformats.org/drawingml/2006/main">
             <a:pPr algn="r">
               <a:buNone/>
-              <a:defRPr sz="750" b="0" i="0">
+              <a:defRPr sz="900" b="0" i="0">
                 <a:solidFill>
                   <a:srgbClr val="E89CB1"/>
                 </a:solidFill>
@@ -9612,7 +9653,7 @@
               </a:defRPr>
             </a:pPr>
             <a:r>
-              <a:rPr sz="750" b="0" i="0">
+              <a:rPr sz="900" b="0" i="0">
                 <a:solidFill>
                   <a:srgbClr val="E89CB1"/>
                 </a:solidFill>

</xml_diff>